<commit_message>
Launch WORK token dashboard domain
</commit_message>
<xml_diff>
--- a/output/proofofwork-general-deck.pptx
+++ b/output/proofofwork-general-deck.pptx
@@ -14,6 +14,7 @@
     <p:sldId id="265" r:id="rId10"/>
     <p:sldId id="266" r:id="rId11"/>
     <p:sldId id="267" r:id="rId12"/>
+    <p:sldId id="268" r:id="rId13"/>
   </p:sldIdLst>
   <p:sldSz cx="12191695" cy="6858000" type="wide"/>
   <p:notesSz cx="6858000" cy="9144000"/>
@@ -162,12 +163,12 @@
           <a:p>
             <a:pPr/>
             <a:r>
-              <a:rPr lang="en-US" sz="1850">
-                <a:solidFill>
-                  <a:srgbClr val="1f2937"/>
-                </a:solidFill>
-              </a:rPr>
-              <a:t>Identity, mail, files, pages, marketplace actions, logs, and growth signals written to Bitcoin.</a:t>
+              <a:rPr lang="en-US" sz="1700">
+                <a:solidFill>
+                  <a:srgbClr val="1f2937"/>
+                </a:solidFill>
+              </a:rPr>
+              <a:t>Identity, mail, files, pages, marketplace actions, Pay2Speak funding, token mints, logs, and growth signals written to Bitcoin.</a:t>
             </a:r>
           </a:p>
         </p:txBody>
@@ -305,7 +306,7 @@
                   <a:srgbClr val="111827"/>
                 </a:solidFill>
               </a:rPr>
-              <a:t>Log And Growth</a:t>
+              <a:t>Tokens</a:t>
             </a:r>
           </a:p>
         </p:txBody>
@@ -340,95 +341,73 @@
                   <a:srgbClr val="1f2937"/>
                 </a:solidFill>
               </a:rPr>
-              <a:t>Log is the public Bitcoin Computer activity feed.</a:t>
-            </a:r>
-          </a:p>
-          <a:p>
-            <a:pPr/>
-            <a:r>
-              <a:rPr lang="en-US" sz="1700">
-                <a:solidFill>
-                  <a:srgbClr val="1f2937"/>
-                </a:solidFill>
-              </a:rPr>
-              <a:t>It indexes registrations, receiver updates, transfers, listings, purchases, messages, replies, files, attachments, and Browser-readable pages.</a:t>
-            </a:r>
-          </a:p>
-          <a:p>
-            <a:pPr/>
-            <a:r>
-              <a:rPr lang="en-US" sz="1700">
-                <a:solidFill>
-                  <a:srgbClr val="1f2937"/>
-                </a:solidFill>
-              </a:rPr>
-              <a:t>Growth compares the canonical success-case model against real confirmed network value in sats and USD.</a:t>
-            </a:r>
-          </a:p>
-          <a:p>
-            <a:pPr/>
-            <a:r>
-              <a:rPr lang="en-US" sz="2050">
-                <a:solidFill>
-                  <a:srgbClr val="1f2937"/>
-                </a:solidFill>
-              </a:rPr>
-              <a:t>The model adds every new product with consistent inputs:</a:t>
-            </a:r>
-          </a:p>
-          <a:p>
-            <a:pPr marL="342900" indent="-171450"/>
-            <a:r>
-              <a:rPr lang="en-US" sz="2050">
-                <a:solidFill>
-                  <a:srgbClr val="374151"/>
-                </a:solidFill>
-              </a:rPr>
-              <a:t>Real chain metrics.</a:t>
-            </a:r>
-          </a:p>
-          <a:p>
-            <a:pPr marL="342900" indent="-171450"/>
-            <a:r>
-              <a:rPr lang="en-US" sz="2050">
-                <a:solidFill>
-                  <a:srgbClr val="374151"/>
-                </a:solidFill>
-              </a:rPr>
-              <a:t>Usage assumptions.</a:t>
-            </a:r>
-          </a:p>
-          <a:p>
-            <a:pPr marL="342900" indent="-171450"/>
-            <a:r>
-              <a:rPr lang="en-US" sz="2050">
-                <a:solidFill>
-                  <a:srgbClr val="374151"/>
-                </a:solidFill>
-              </a:rPr>
-              <a:t>Value assumptions.</a:t>
-            </a:r>
-          </a:p>
-          <a:p>
-            <a:pPr marL="342900" indent="-171450"/>
-            <a:r>
-              <a:rPr lang="en-US" sz="2050">
-                <a:solidFill>
-                  <a:srgbClr val="374151"/>
-                </a:solidFill>
-              </a:rPr>
-              <a:t>Fee elasticity.</a:t>
-            </a:r>
-          </a:p>
-          <a:p>
-            <a:pPr marL="342900" indent="-171450"/>
-            <a:r>
-              <a:rPr lang="en-US" sz="2050">
-                <a:solidFill>
-                  <a:srgbClr val="374151"/>
-                </a:solidFill>
-              </a:rPr>
-              <a:t>Blockspace accounting.</a:t>
+              <a:t>Tokens are mint-first and Bitcoin-readable.</a:t>
+            </a:r>
+          </a:p>
+          <a:p>
+            <a:pPr/>
+            <a:r>
+              <a:rPr lang="en-US" sz="2050">
+                <a:solidFill>
+                  <a:srgbClr val="1f2937"/>
+                </a:solidFill>
+              </a:rPr>
+              <a:t>token.proofofwork.me</a:t>
+            </a:r>
+          </a:p>
+          <a:p>
+            <a:pPr/>
+            <a:r>
+              <a:rPr lang="en-US" sz="2050">
+                <a:solidFill>
+                  <a:srgbClr val="1f2937"/>
+                </a:solidFill>
+              </a:rPr>
+              <a:t>work.proofofwork.me</a:t>
+            </a:r>
+          </a:p>
+          <a:p>
+            <a:pPr/>
+            <a:r>
+              <a:rPr lang="en-US" sz="2050">
+                <a:solidFill>
+                  <a:srgbClr val="1f2937"/>
+                </a:solidFill>
+              </a:rPr>
+              <a:t>Creation pays the token index.</a:t>
+            </a:r>
+          </a:p>
+          <a:p>
+            <a:pPr/>
+            <a:r>
+              <a:rPr lang="en-US" sz="2050">
+                <a:solidFill>
+                  <a:srgbClr val="1f2937"/>
+                </a:solidFill>
+              </a:rPr>
+              <a:t>Mints pay each token registry directly at the owner-set price.</a:t>
+            </a:r>
+          </a:p>
+          <a:p>
+            <a:pPr/>
+            <a:r>
+              <a:rPr lang="en-US" sz="1850">
+                <a:solidFill>
+                  <a:srgbClr val="1f2937"/>
+                </a:solidFill>
+              </a:rPr>
+              <a:t>WORK starts with 21,000,000 max supply, 1,000 WORK per mint, and 1,000 sats per mint.</a:t>
+            </a:r>
+          </a:p>
+          <a:p>
+            <a:pPr/>
+            <a:r>
+              <a:rPr lang="en-US" sz="2050">
+                <a:solidFill>
+                  <a:srgbClr val="1f2937"/>
+                </a:solidFill>
+              </a:rPr>
+              <a:t>That is exactly 1 sat per WORK.</a:t>
             </a:r>
           </a:p>
         </p:txBody>
@@ -566,7 +545,7 @@
                   <a:srgbClr val="111827"/>
                 </a:solidFill>
               </a:rPr>
-              <a:t>Agent-Readable By Design</a:t>
+              <a:t>Log And Growth</a:t>
             </a:r>
           </a:p>
         </p:txBody>
@@ -601,18 +580,40 @@
                   <a:srgbClr val="1f2937"/>
                 </a:solidFill>
               </a:rPr>
-              <a:t>Agents need identity, memory, money, and verifiable state.</a:t>
-            </a:r>
-          </a:p>
-          <a:p>
-            <a:pPr/>
-            <a:r>
-              <a:rPr lang="en-US" sz="2050">
-                <a:solidFill>
-                  <a:srgbClr val="1f2937"/>
-                </a:solidFill>
-              </a:rPr>
-              <a:t>ProofOfWork.Me gives agents:</a:t>
+              <a:t>Log is the public Bitcoin Computer activity feed.</a:t>
+            </a:r>
+          </a:p>
+          <a:p>
+            <a:pPr/>
+            <a:r>
+              <a:rPr lang="en-US" sz="1700">
+                <a:solidFill>
+                  <a:srgbClr val="1f2937"/>
+                </a:solidFill>
+              </a:rPr>
+              <a:t>It indexes registrations, receiver updates, transfers, listings, purchases, messages, replies, files, attachments, Browser-readable pages, Pay2Speak funding, token creations, and token mints.</a:t>
+            </a:r>
+          </a:p>
+          <a:p>
+            <a:pPr/>
+            <a:r>
+              <a:rPr lang="en-US" sz="1700">
+                <a:solidFill>
+                  <a:srgbClr val="1f2937"/>
+                </a:solidFill>
+              </a:rPr>
+              <a:t>Growth compares the canonical success-case model against real confirmed network value in sats and USD.</a:t>
+            </a:r>
+          </a:p>
+          <a:p>
+            <a:pPr/>
+            <a:r>
+              <a:rPr lang="en-US" sz="2050">
+                <a:solidFill>
+                  <a:srgbClr val="1f2937"/>
+                </a:solidFill>
+              </a:rPr>
+              <a:t>The model adds every new product with consistent inputs:</a:t>
             </a:r>
           </a:p>
           <a:p>
@@ -623,7 +624,7 @@
                   <a:srgbClr val="374151"/>
                 </a:solidFill>
               </a:rPr>
-              <a:t>Handles.</a:t>
+              <a:t>Real chain metrics.</a:t>
             </a:r>
           </a:p>
           <a:p>
@@ -634,7 +635,7 @@
                   <a:srgbClr val="374151"/>
                 </a:solidFill>
               </a:rPr>
-              <a:t>Chain-readable messages.</a:t>
+              <a:t>Usage assumptions.</a:t>
             </a:r>
           </a:p>
           <a:p>
@@ -645,7 +646,7 @@
                   <a:srgbClr val="374151"/>
                 </a:solidFill>
               </a:rPr>
-              <a:t>Sats with every interaction.</a:t>
+              <a:t>Value assumptions.</a:t>
             </a:r>
           </a:p>
           <a:p>
@@ -656,7 +657,7 @@
                   <a:srgbClr val="374151"/>
                 </a:solidFill>
               </a:rPr>
-              <a:t>Durable files and instructions.</a:t>
+              <a:t>Fee elasticity.</a:t>
             </a:r>
           </a:p>
           <a:p>
@@ -667,29 +668,7 @@
                   <a:srgbClr val="374151"/>
                 </a:solidFill>
               </a:rPr>
-              <a:t>Public ownership and marketplace records.</a:t>
-            </a:r>
-          </a:p>
-          <a:p>
-            <a:pPr marL="342900" indent="-171450"/>
-            <a:r>
-              <a:rPr lang="en-US" sz="2050">
-                <a:solidFill>
-                  <a:srgbClr val="374151"/>
-                </a:solidFill>
-              </a:rPr>
-              <a:t>Local wallet authority controlled by humans.</a:t>
-            </a:r>
-          </a:p>
-          <a:p>
-            <a:pPr/>
-            <a:r>
-              <a:rPr lang="en-US" sz="2050" b="1">
-                <a:solidFill>
-                  <a:srgbClr val="1f2937"/>
-                </a:solidFill>
-              </a:rPr>
-              <a:t>Humans sign. Agents verify.</a:t>
+              <a:t>Blockspace accounting.</a:t>
             </a:r>
           </a:p>
         </p:txBody>
@@ -827,7 +806,7 @@
                   <a:srgbClr val="111827"/>
                 </a:solidFill>
               </a:rPr>
-              <a:t>The Final Network</a:t>
+              <a:t>Agent-Readable By Design</a:t>
             </a:r>
           </a:p>
         </p:txBody>
@@ -862,6 +841,267 @@
                   <a:srgbClr val="1f2937"/>
                 </a:solidFill>
               </a:rPr>
+              <a:t>Agents need identity, memory, money, and verifiable state.</a:t>
+            </a:r>
+          </a:p>
+          <a:p>
+            <a:pPr/>
+            <a:r>
+              <a:rPr lang="en-US" sz="2050">
+                <a:solidFill>
+                  <a:srgbClr val="1f2937"/>
+                </a:solidFill>
+              </a:rPr>
+              <a:t>ProofOfWork.Me gives agents:</a:t>
+            </a:r>
+          </a:p>
+          <a:p>
+            <a:pPr marL="342900" indent="-171450"/>
+            <a:r>
+              <a:rPr lang="en-US" sz="2050">
+                <a:solidFill>
+                  <a:srgbClr val="374151"/>
+                </a:solidFill>
+              </a:rPr>
+              <a:t>Handles.</a:t>
+            </a:r>
+          </a:p>
+          <a:p>
+            <a:pPr marL="342900" indent="-171450"/>
+            <a:r>
+              <a:rPr lang="en-US" sz="2050">
+                <a:solidFill>
+                  <a:srgbClr val="374151"/>
+                </a:solidFill>
+              </a:rPr>
+              <a:t>Chain-readable messages.</a:t>
+            </a:r>
+          </a:p>
+          <a:p>
+            <a:pPr marL="342900" indent="-171450"/>
+            <a:r>
+              <a:rPr lang="en-US" sz="2050">
+                <a:solidFill>
+                  <a:srgbClr val="374151"/>
+                </a:solidFill>
+              </a:rPr>
+              <a:t>Sats with every interaction.</a:t>
+            </a:r>
+          </a:p>
+          <a:p>
+            <a:pPr marL="342900" indent="-171450"/>
+            <a:r>
+              <a:rPr lang="en-US" sz="2050">
+                <a:solidFill>
+                  <a:srgbClr val="374151"/>
+                </a:solidFill>
+              </a:rPr>
+              <a:t>Durable files and instructions.</a:t>
+            </a:r>
+          </a:p>
+          <a:p>
+            <a:pPr marL="342900" indent="-171450"/>
+            <a:r>
+              <a:rPr lang="en-US" sz="2050">
+                <a:solidFill>
+                  <a:srgbClr val="374151"/>
+                </a:solidFill>
+              </a:rPr>
+              <a:t>Public ownership, marketplace, funding, and token records.</a:t>
+            </a:r>
+          </a:p>
+          <a:p>
+            <a:pPr marL="342900" indent="-171450"/>
+            <a:r>
+              <a:rPr lang="en-US" sz="2050">
+                <a:solidFill>
+                  <a:srgbClr val="374151"/>
+                </a:solidFill>
+              </a:rPr>
+              <a:t>Local wallet authority controlled by humans.</a:t>
+            </a:r>
+          </a:p>
+          <a:p>
+            <a:pPr/>
+            <a:r>
+              <a:rPr lang="en-US" sz="2050" b="1">
+                <a:solidFill>
+                  <a:srgbClr val="1f2937"/>
+                </a:solidFill>
+              </a:rPr>
+              <a:t>Humans sign. Agents verify.</a:t>
+            </a:r>
+          </a:p>
+        </p:txBody>
+      </p:sp>
+      <p:sp>
+        <p:nvSpPr>
+          <p:cNvPr id="5" name="Footer"/>
+          <p:cNvSpPr txBox="1"/>
+          <p:nvPr/>
+        </p:nvSpPr>
+        <p:spPr>
+          <a:xfrm>
+            <a:off x="685800" y="6355080"/>
+            <a:ext cx="10698480" cy="256032"/>
+          </a:xfrm>
+          <a:prstGeom prst="rect">
+            <a:avLst/>
+          </a:prstGeom>
+          <a:noFill/>
+          <a:ln>
+            <a:noFill/>
+          </a:ln>
+        </p:spPr>
+        <p:txBody>
+          <a:bodyPr wrap="square" anchor="t"/>
+          <a:lstStyle/>
+          <a:p>
+            <a:pPr/>
+            <a:r>
+              <a:rPr lang="en-US" sz="1050">
+                <a:solidFill>
+                  <a:srgbClr val="64748b"/>
+                </a:solidFill>
+              </a:rPr>
+              <a:t>Bitcoin Computer · local-first · on-chain · agent-readable</a:t>
+            </a:r>
+          </a:p>
+        </p:txBody>
+      </p:sp>
+    </p:spTree>
+  </p:cSld>
+  <p:clrMapOvr>
+    <a:masterClrMapping/>
+  </p:clrMapOvr>
+</p:sld>
+</file>
+
+<file path=ppt/slides/slide13.xml><?xml version="1.0" encoding="utf-8"?>
+<p:sld xmlns:a="http://schemas.openxmlformats.org/drawingml/2006/main" xmlns:r="http://schemas.openxmlformats.org/officeDocument/2006/relationships" xmlns:p="http://schemas.openxmlformats.org/presentationml/2006/main">
+  <p:cSld>
+    <p:bg>
+      <p:bgPr>
+        <a:solidFill>
+          <a:srgbClr val="f8fafc"/>
+        </a:solidFill>
+        <a:effectLst/>
+      </p:bgPr>
+    </p:bg>
+    <p:spTree>
+      <p:nvGrpSpPr>
+        <p:cNvPr id="1" name=""/>
+        <p:cNvGrpSpPr/>
+        <p:nvPr/>
+      </p:nvGrpSpPr>
+      <p:grpSpPr>
+        <a:xfrm>
+          <a:off x="0" y="0"/>
+          <a:ext cx="0" cy="0"/>
+          <a:chOff x="0" y="0"/>
+          <a:chExt cx="0" cy="0"/>
+        </a:xfrm>
+      </p:grpSpPr>
+      <p:sp>
+        <p:nvSpPr>
+          <p:cNvPr id="2" name="Kicker"/>
+          <p:cNvSpPr txBox="1"/>
+          <p:nvPr/>
+        </p:nvSpPr>
+        <p:spPr>
+          <a:xfrm>
+            <a:off x="640080" y="411480"/>
+            <a:ext cx="10881360" cy="320040"/>
+          </a:xfrm>
+          <a:prstGeom prst="rect">
+            <a:avLst/>
+          </a:prstGeom>
+          <a:noFill/>
+          <a:ln>
+            <a:noFill/>
+          </a:ln>
+        </p:spPr>
+        <p:txBody>
+          <a:bodyPr wrap="square" anchor="t"/>
+          <a:lstStyle/>
+          <a:p>
+            <a:pPr/>
+            <a:r>
+              <a:rPr lang="en-US" sz="1250" b="1">
+                <a:solidFill>
+                  <a:srgbClr val="0a84ff"/>
+                </a:solidFill>
+              </a:rPr>
+              <a:t>PROOFOFWORK.ME</a:t>
+            </a:r>
+          </a:p>
+        </p:txBody>
+      </p:sp>
+      <p:sp>
+        <p:nvSpPr>
+          <p:cNvPr id="3" name="Title"/>
+          <p:cNvSpPr txBox="1"/>
+          <p:nvPr/>
+        </p:nvSpPr>
+        <p:spPr>
+          <a:xfrm>
+            <a:off x="640080" y="868680"/>
+            <a:ext cx="10881360" cy="914400"/>
+          </a:xfrm>
+          <a:prstGeom prst="rect">
+            <a:avLst/>
+          </a:prstGeom>
+          <a:noFill/>
+          <a:ln>
+            <a:noFill/>
+          </a:ln>
+        </p:spPr>
+        <p:txBody>
+          <a:bodyPr wrap="square" anchor="t"/>
+          <a:lstStyle/>
+          <a:p>
+            <a:pPr/>
+            <a:r>
+              <a:rPr lang="en-US" sz="3800" b="1">
+                <a:solidFill>
+                  <a:srgbClr val="111827"/>
+                </a:solidFill>
+              </a:rPr>
+              <a:t>The Final Network</a:t>
+            </a:r>
+          </a:p>
+        </p:txBody>
+      </p:sp>
+      <p:sp>
+        <p:nvSpPr>
+          <p:cNvPr id="4" name="Body"/>
+          <p:cNvSpPr txBox="1"/>
+          <p:nvPr/>
+        </p:nvSpPr>
+        <p:spPr>
+          <a:xfrm>
+            <a:off x="685800" y="1965960"/>
+            <a:ext cx="10698480" cy="4480560"/>
+          </a:xfrm>
+          <a:prstGeom prst="rect">
+            <a:avLst/>
+          </a:prstGeom>
+          <a:noFill/>
+          <a:ln>
+            <a:noFill/>
+          </a:ln>
+        </p:spPr>
+        <p:txBody>
+          <a:bodyPr wrap="square" anchor="t"/>
+          <a:lstStyle/>
+          <a:p>
+            <a:pPr/>
+            <a:r>
+              <a:rPr lang="en-US" sz="2050">
+                <a:solidFill>
+                  <a:srgbClr val="1f2937"/>
+                </a:solidFill>
+              </a:rPr>
               <a:t>ProofOfWork.Me is a new interface for Bitcoin.</a:t>
             </a:r>
           </a:p>
@@ -939,6 +1179,39 @@
                   <a:srgbClr val="1f2937"/>
                 </a:solidFill>
               </a:rPr>
+              <a:t>Pay2Speak.</a:t>
+            </a:r>
+          </a:p>
+          <a:p>
+            <a:pPr/>
+            <a:r>
+              <a:rPr lang="en-US" sz="2050">
+                <a:solidFill>
+                  <a:srgbClr val="1f2937"/>
+                </a:solidFill>
+              </a:rPr>
+              <a:t>Tokens.</a:t>
+            </a:r>
+          </a:p>
+          <a:p>
+            <a:pPr/>
+            <a:r>
+              <a:rPr lang="en-US" sz="2050">
+                <a:solidFill>
+                  <a:srgbClr val="1f2937"/>
+                </a:solidFill>
+              </a:rPr>
+              <a:t>WORK.</a:t>
+            </a:r>
+          </a:p>
+          <a:p>
+            <a:pPr/>
+            <a:r>
+              <a:rPr lang="en-US" sz="2050">
+                <a:solidFill>
+                  <a:srgbClr val="1f2937"/>
+                </a:solidFill>
+              </a:rPr>
               <a:t>Log.</a:t>
             </a:r>
           </a:p>
@@ -962,39 +1235,6 @@
                 </a:solidFill>
               </a:rPr>
               <a:t>Agents.</a:t>
-            </a:r>
-          </a:p>
-          <a:p>
-            <a:pPr/>
-            <a:r>
-              <a:rPr lang="en-US" sz="2050">
-                <a:solidFill>
-                  <a:srgbClr val="1f2937"/>
-                </a:solidFill>
-              </a:rPr>
-              <a:t>Value.</a:t>
-            </a:r>
-          </a:p>
-          <a:p>
-            <a:pPr/>
-            <a:r>
-              <a:rPr lang="en-US" sz="2050">
-                <a:solidFill>
-                  <a:srgbClr val="1f2937"/>
-                </a:solidFill>
-              </a:rPr>
-              <a:t>The final network is not a platform.</a:t>
-            </a:r>
-          </a:p>
-          <a:p>
-            <a:pPr/>
-            <a:r>
-              <a:rPr lang="en-US" sz="2050">
-                <a:solidFill>
-                  <a:srgbClr val="1f2937"/>
-                </a:solidFill>
-              </a:rPr>
-              <a:t>It is proof of work.</a:t>
             </a:r>
           </a:p>
         </p:txBody>

</xml_diff>